<commit_message>
Complete 5-phase plan: Update dashboard, landing page, reports, and secure secrets
</commit_message>
<xml_diff>
--- a/reports/Project_Presentation_Deck.pptx
+++ b/reports/Project_Presentation_Deck.pptx
@@ -3136,12 +3136,12 @@
           <a:lstStyle/>
           <a:p>
             <a:r>
-              <a:t>Capstone Project Presentation</a:t>
-            </a:r>
-          </a:p>
-          <a:p>
-            <a:r>
-              <a:t>Bluestock Fintech</a:t>
+              <a:t>Capstone Project - Bluestock Fintech</a:t>
+            </a:r>
+          </a:p>
+          <a:p>
+            <a:r>
+              <a:t>40 Schemes | 46k+ NAV Records | 32k+ Transactions</a:t>
             </a:r>
           </a:p>
         </p:txBody>
@@ -3178,34 +3178,64 @@
         <p:txBody>
           <a:bodyPr/>
           <a:lstStyle/>
-          <a:p>
-            <a:r>
-              <a:t>Portfolio Holdings &amp; Sector Exposure</a:t>
-            </a:r>
-          </a:p>
-        </p:txBody>
-      </p:sp>
-      <p:sp>
-        <p:nvSpPr>
-          <p:cNvPr id="3" name="Content Placeholder 2"/>
-          <p:cNvSpPr>
-            <a:spLocks noGrp="1"/>
-          </p:cNvSpPr>
-          <p:nvPr>
-            <p:ph idx="1"/>
-          </p:nvPr>
-        </p:nvSpPr>
-        <p:spPr/>
-        <p:txBody>
-          <a:bodyPr/>
-          <a:lstStyle/>
-          <a:p>
-            <a:r>
-              <a:t>Key points for Portfolio Holdings &amp; Sector Exposure go here.</a:t>
-            </a:r>
-          </a:p>
-        </p:txBody>
-      </p:sp>
+          <a:p/>
+        </p:txBody>
+      </p:sp>
+      <p:sp>
+        <p:nvSpPr>
+          <p:cNvPr id="3" name="TextBox 2"/>
+          <p:cNvSpPr txBox="1"/>
+          <p:nvPr/>
+        </p:nvSpPr>
+        <p:spPr>
+          <a:xfrm>
+            <a:off x="457200" y="274320"/>
+            <a:ext cx="8229600" cy="731520"/>
+          </a:xfrm>
+          <a:prstGeom prst="rect">
+            <a:avLst/>
+          </a:prstGeom>
+          <a:noFill/>
+        </p:spPr>
+        <p:txBody>
+          <a:bodyPr wrap="none">
+            <a:spAutoFit/>
+          </a:bodyPr>
+          <a:lstStyle/>
+          <a:p>
+            <a:pPr>
+              <a:defRPr sz="2400" b="1"/>
+            </a:pPr>
+            <a:r>
+              <a:t>Cross-Fund Correlation Matrix</a:t>
+            </a:r>
+          </a:p>
+        </p:txBody>
+      </p:sp>
+      <p:pic>
+        <p:nvPicPr>
+          <p:cNvPr id="4" name="Picture 3" descr="08_Correlation_Matrix.png"/>
+          <p:cNvPicPr>
+            <a:picLocks noChangeAspect="1"/>
+          </p:cNvPicPr>
+          <p:nvPr/>
+        </p:nvPicPr>
+        <p:blipFill>
+          <a:blip r:embed="rId2"/>
+          <a:stretch>
+            <a:fillRect/>
+          </a:stretch>
+        </p:blipFill>
+        <p:spPr>
+          <a:xfrm>
+            <a:off x="457200" y="1188720"/>
+            <a:ext cx="8229600" cy="6583680"/>
+          </a:xfrm>
+          <a:prstGeom prst="rect">
+            <a:avLst/>
+          </a:prstGeom>
+        </p:spPr>
+      </p:pic>
     </p:spTree>
   </p:cSld>
   <p:clrMapOvr>
@@ -3240,7 +3270,7 @@
           <a:lstStyle/>
           <a:p>
             <a:r>
-              <a:t>Recommender System Demo</a:t>
+              <a:t>Fund Scorecard &amp; Recommender</a:t>
             </a:r>
           </a:p>
         </p:txBody>
@@ -3261,7 +3291,31 @@
           <a:lstStyle/>
           <a:p>
             <a:r>
-              <a:t>Key points for Recommender System Demo go here.</a:t>
+              <a:t>Composite Score (0-100): weighted rank across 5 dimensions</a:t>
+            </a:r>
+          </a:p>
+          <a:p>
+            <a:pPr lvl="1"/>
+            <a:r>
+              <a:t>30% CAGR 3Y + 25% Sharpe + 20% Alpha + 15% Expense + 10% Drawdown</a:t>
+            </a:r>
+          </a:p>
+          <a:p>
+            <a:pPr lvl="1"/>
+            <a:r>
+              <a:t>Risk-based filtering: Low / Moderate / High</a:t>
+            </a:r>
+          </a:p>
+          <a:p>
+            <a:pPr lvl="1"/>
+            <a:r>
+              <a:t>Interactive radar chart comparison of top recommendations</a:t>
+            </a:r>
+          </a:p>
+          <a:p>
+            <a:pPr lvl="1"/>
+            <a:r>
+              <a:t>Projected returns calculator (SIP &amp; Lumpsum modes)</a:t>
             </a:r>
           </a:p>
         </p:txBody>
@@ -3321,7 +3375,31 @@
           <a:lstStyle/>
           <a:p>
             <a:r>
-              <a:t>Key points for Conclusion &amp; Future Scope go here.</a:t>
+              <a:t>All capstone requirements fulfilled with bonus features</a:t>
+            </a:r>
+          </a:p>
+          <a:p>
+            <a:pPr lvl="1"/>
+            <a:r>
+              <a:t>Production-grade authentication with Google OAuth 2.0</a:t>
+            </a:r>
+          </a:p>
+          <a:p>
+            <a:pPr lvl="1"/>
+            <a:r>
+              <a:t>Future: Real-time streaming, ML predictions, portfolio optimization</a:t>
+            </a:r>
+          </a:p>
+          <a:p>
+            <a:pPr lvl="1"/>
+            <a:r>
+              <a:t>Future: Mobile PWA, automated monthly email reports</a:t>
+            </a:r>
+          </a:p>
+          <a:p>
+            <a:pPr lvl="1"/>
+            <a:r>
+              <a:t>Disclaimer: Past performance != future returns. Consult a SEBI advisor.</a:t>
             </a:r>
           </a:p>
         </p:txBody>
@@ -3381,19 +3459,25 @@
           <a:lstStyle/>
           <a:p>
             <a:r>
-              <a:t>Objective: Build an end-to-end MF analytics platform.</a:t>
+              <a:t>Objective: Build an end-to-end mutual fund analytics platform.</a:t>
             </a:r>
           </a:p>
           <a:p>
             <a:pPr lvl="1"/>
             <a:r>
-              <a:t>Data Scale: 40 AMCs, 46k+ NAV records, 32k+ investor txns.</a:t>
+              <a:t>Data Scale: 40 AMFI codes, 10 AMCs, 3-year historical data.</a:t>
             </a:r>
           </a:p>
           <a:p>
             <a:pPr lvl="1"/>
             <a:r>
-              <a:t>Tech Stack: Python, SQLite, Pandas, Streamlit, Plotly.</a:t>
+              <a:t>Features: ETL Pipeline, Star Schema, Analytical Queries, Interactive Dashboard.</a:t>
+            </a:r>
+          </a:p>
+          <a:p>
+            <a:pPr lvl="1"/>
+            <a:r>
+              <a:t>Bonus: Auth Gateway, Fund Recommender, PowerBI Connector, Landing Page.</a:t>
             </a:r>
           </a:p>
         </p:txBody>
@@ -3453,13 +3537,31 @@
           <a:lstStyle/>
           <a:p>
             <a:r>
-              <a:t>ETL Pipeline: Raw CSV + API -&gt; Pandas -&gt; SQLite</a:t>
+              <a:t>ETL: Raw CSV + API → Pandas → PostgreSQL (Neon Cloud)</a:t>
             </a:r>
           </a:p>
           <a:p>
             <a:pPr lvl="1"/>
             <a:r>
-              <a:t>Star Schema: dim_fund, fact_nav, fact_transactions, etc.</a:t>
+              <a:t>Star Schema: dim_fund, dim_date → fact_nav, fact_transactions, etc.</a:t>
+            </a:r>
+          </a:p>
+          <a:p>
+            <a:pPr lvl="1"/>
+            <a:r>
+              <a:t>Auth: FastAPI + Google OAuth 2.0 + JWT Tokens</a:t>
+            </a:r>
+          </a:p>
+          <a:p>
+            <a:pPr lvl="1"/>
+            <a:r>
+              <a:t>Dashboard: Streamlit + Plotly (6 interactive pages)</a:t>
+            </a:r>
+          </a:p>
+          <a:p>
+            <a:pPr lvl="1"/>
+            <a:r>
+              <a:t>Landing: React + Vite + TailwindCSS with shader animations</a:t>
             </a:r>
           </a:p>
         </p:txBody>
@@ -3519,7 +3621,25 @@
           <a:lstStyle/>
           <a:p>
             <a:r>
-              <a:t>Key points for Market Overview &amp; Trends go here.</a:t>
+              <a:t>Equity AUM growth: +41% (2023-2025)</a:t>
+            </a:r>
+          </a:p>
+          <a:p>
+            <a:pPr lvl="1"/>
+            <a:r>
+              <a:t>SIP milestone: Rs. 31,002 Cr monthly inflows (Dec 2025)</a:t>
+            </a:r>
+          </a:p>
+          <a:p>
+            <a:pPr lvl="1"/>
+            <a:r>
+              <a:t>Folio growth: 2.1x expansion in total industry folios</a:t>
+            </a:r>
+          </a:p>
+          <a:p>
+            <a:pPr lvl="1"/>
+            <a:r>
+              <a:t>Mid-Cap alpha: +3.2% outperformance vs Large-Cap (3Y)</a:t>
             </a:r>
           </a:p>
         </p:txBody>
@@ -3556,34 +3676,64 @@
         <p:txBody>
           <a:bodyPr/>
           <a:lstStyle/>
-          <a:p>
-            <a:r>
-              <a:t>Fund Performance &amp; Risk</a:t>
-            </a:r>
-          </a:p>
-        </p:txBody>
-      </p:sp>
-      <p:sp>
-        <p:nvSpPr>
-          <p:cNvPr id="3" name="Content Placeholder 2"/>
-          <p:cNvSpPr>
-            <a:spLocks noGrp="1"/>
-          </p:cNvSpPr>
-          <p:nvPr>
-            <p:ph idx="1"/>
-          </p:nvPr>
-        </p:nvSpPr>
-        <p:spPr/>
-        <p:txBody>
-          <a:bodyPr/>
-          <a:lstStyle/>
-          <a:p>
-            <a:r>
-              <a:t>Key points for Fund Performance &amp; Risk go here.</a:t>
-            </a:r>
-          </a:p>
-        </p:txBody>
-      </p:sp>
+          <a:p/>
+        </p:txBody>
+      </p:sp>
+      <p:sp>
+        <p:nvSpPr>
+          <p:cNvPr id="3" name="TextBox 2"/>
+          <p:cNvSpPr txBox="1"/>
+          <p:nvPr/>
+        </p:nvSpPr>
+        <p:spPr>
+          <a:xfrm>
+            <a:off x="457200" y="274320"/>
+            <a:ext cx="8229600" cy="731520"/>
+          </a:xfrm>
+          <a:prstGeom prst="rect">
+            <a:avLst/>
+          </a:prstGeom>
+          <a:noFill/>
+        </p:spPr>
+        <p:txBody>
+          <a:bodyPr wrap="none">
+            <a:spAutoFit/>
+          </a:bodyPr>
+          <a:lstStyle/>
+          <a:p>
+            <a:pPr>
+              <a:defRPr sz="2400" b="1"/>
+            </a:pPr>
+            <a:r>
+              <a:t>NAV Trend Lines</a:t>
+            </a:r>
+          </a:p>
+        </p:txBody>
+      </p:sp>
+      <p:pic>
+        <p:nvPicPr>
+          <p:cNvPr id="4" name="Picture 3" descr="01_NAV_Trend_Lines.png"/>
+          <p:cNvPicPr>
+            <a:picLocks noChangeAspect="1"/>
+          </p:cNvPicPr>
+          <p:nvPr/>
+        </p:nvPicPr>
+        <p:blipFill>
+          <a:blip r:embed="rId2"/>
+          <a:stretch>
+            <a:fillRect/>
+          </a:stretch>
+        </p:blipFill>
+        <p:spPr>
+          <a:xfrm>
+            <a:off x="457200" y="1188720"/>
+            <a:ext cx="8229600" cy="4114800"/>
+          </a:xfrm>
+          <a:prstGeom prst="rect">
+            <a:avLst/>
+          </a:prstGeom>
+        </p:spPr>
+      </p:pic>
     </p:spTree>
   </p:cSld>
   <p:clrMapOvr>
@@ -3618,7 +3768,7 @@
           <a:lstStyle/>
           <a:p>
             <a:r>
-              <a:t>Alpha &amp; Beta Analysis</a:t>
+              <a:t>Fund Performance &amp; Risk</a:t>
             </a:r>
           </a:p>
         </p:txBody>
@@ -3639,7 +3789,25 @@
           <a:lstStyle/>
           <a:p>
             <a:r>
-              <a:t>Key points for Alpha &amp; Beta Analysis go here.</a:t>
+              <a:t>Computed: Sharpe Ratio, Sortino Ratio, Alpha, Beta for all 40 schemes</a:t>
+            </a:r>
+          </a:p>
+          <a:p>
+            <a:pPr lvl="1"/>
+            <a:r>
+              <a:t>Maximum Drawdown analysis with peak, trough, and recovery dates</a:t>
+            </a:r>
+          </a:p>
+          <a:p>
+            <a:pPr lvl="1"/>
+            <a:r>
+              <a:t>VaR (95%) and CVaR (Expected Shortfall) computed for tail risk</a:t>
+            </a:r>
+          </a:p>
+          <a:p>
+            <a:pPr lvl="1"/>
+            <a:r>
+              <a:t>Direct plans consistently outperform Regular plans</a:t>
             </a:r>
           </a:p>
         </p:txBody>
@@ -3676,34 +3844,64 @@
         <p:txBody>
           <a:bodyPr/>
           <a:lstStyle/>
-          <a:p>
-            <a:r>
-              <a:t>Value at Risk (VaR) Breakdown</a:t>
-            </a:r>
-          </a:p>
-        </p:txBody>
-      </p:sp>
-      <p:sp>
-        <p:nvSpPr>
-          <p:cNvPr id="3" name="Content Placeholder 2"/>
-          <p:cNvSpPr>
-            <a:spLocks noGrp="1"/>
-          </p:cNvSpPr>
-          <p:nvPr>
-            <p:ph idx="1"/>
-          </p:nvPr>
-        </p:nvSpPr>
-        <p:spPr/>
-        <p:txBody>
-          <a:bodyPr/>
-          <a:lstStyle/>
-          <a:p>
-            <a:r>
-              <a:t>Key points for Value at Risk (VaR) Breakdown go here.</a:t>
-            </a:r>
-          </a:p>
-        </p:txBody>
-      </p:sp>
+          <a:p/>
+        </p:txBody>
+      </p:sp>
+      <p:sp>
+        <p:nvSpPr>
+          <p:cNvPr id="3" name="TextBox 2"/>
+          <p:cNvSpPr txBox="1"/>
+          <p:nvPr/>
+        </p:nvSpPr>
+        <p:spPr>
+          <a:xfrm>
+            <a:off x="457200" y="274320"/>
+            <a:ext cx="8229600" cy="731520"/>
+          </a:xfrm>
+          <a:prstGeom prst="rect">
+            <a:avLst/>
+          </a:prstGeom>
+          <a:noFill/>
+        </p:spPr>
+        <p:txBody>
+          <a:bodyPr wrap="none">
+            <a:spAutoFit/>
+          </a:bodyPr>
+          <a:lstStyle/>
+          <a:p>
+            <a:pPr>
+              <a:defRPr sz="2400" b="1"/>
+            </a:pPr>
+            <a:r>
+              <a:t>AUM Growth by AMC</a:t>
+            </a:r>
+          </a:p>
+        </p:txBody>
+      </p:sp>
+      <p:pic>
+        <p:nvPicPr>
+          <p:cNvPr id="4" name="Picture 3" descr="02_AUM_Growth_by_AMC.png"/>
+          <p:cNvPicPr>
+            <a:picLocks noChangeAspect="1"/>
+          </p:cNvPicPr>
+          <p:nvPr/>
+        </p:nvPicPr>
+        <p:blipFill>
+          <a:blip r:embed="rId2"/>
+          <a:stretch>
+            <a:fillRect/>
+          </a:stretch>
+        </p:blipFill>
+        <p:spPr>
+          <a:xfrm>
+            <a:off x="457200" y="1188720"/>
+            <a:ext cx="8229600" cy="4114800"/>
+          </a:xfrm>
+          <a:prstGeom prst="rect">
+            <a:avLst/>
+          </a:prstGeom>
+        </p:spPr>
+      </p:pic>
     </p:spTree>
   </p:cSld>
   <p:clrMapOvr>
@@ -3736,34 +3934,64 @@
         <p:txBody>
           <a:bodyPr/>
           <a:lstStyle/>
-          <a:p>
-            <a:r>
-              <a:t>Investor Demographics</a:t>
-            </a:r>
-          </a:p>
-        </p:txBody>
-      </p:sp>
-      <p:sp>
-        <p:nvSpPr>
-          <p:cNvPr id="3" name="Content Placeholder 2"/>
-          <p:cNvSpPr>
-            <a:spLocks noGrp="1"/>
-          </p:cNvSpPr>
-          <p:nvPr>
-            <p:ph idx="1"/>
-          </p:nvPr>
-        </p:nvSpPr>
-        <p:spPr/>
-        <p:txBody>
-          <a:bodyPr/>
-          <a:lstStyle/>
-          <a:p>
-            <a:r>
-              <a:t>Key points for Investor Demographics go here.</a:t>
-            </a:r>
-          </a:p>
-        </p:txBody>
-      </p:sp>
+          <a:p/>
+        </p:txBody>
+      </p:sp>
+      <p:sp>
+        <p:nvSpPr>
+          <p:cNvPr id="3" name="TextBox 2"/>
+          <p:cNvSpPr txBox="1"/>
+          <p:nvPr/>
+        </p:nvSpPr>
+        <p:spPr>
+          <a:xfrm>
+            <a:off x="457200" y="274320"/>
+            <a:ext cx="8229600" cy="731520"/>
+          </a:xfrm>
+          <a:prstGeom prst="rect">
+            <a:avLst/>
+          </a:prstGeom>
+          <a:noFill/>
+        </p:spPr>
+        <p:txBody>
+          <a:bodyPr wrap="none">
+            <a:spAutoFit/>
+          </a:bodyPr>
+          <a:lstStyle/>
+          <a:p>
+            <a:pPr>
+              <a:defRPr sz="2400" b="1"/>
+            </a:pPr>
+            <a:r>
+              <a:t>SIP Inflow Trend</a:t>
+            </a:r>
+          </a:p>
+        </p:txBody>
+      </p:sp>
+      <p:pic>
+        <p:nvPicPr>
+          <p:cNvPr id="4" name="Picture 3" descr="03_SIP_Inflow_Trend.png"/>
+          <p:cNvPicPr>
+            <a:picLocks noChangeAspect="1"/>
+          </p:cNvPicPr>
+          <p:nvPr/>
+        </p:nvPicPr>
+        <p:blipFill>
+          <a:blip r:embed="rId2"/>
+          <a:stretch>
+            <a:fillRect/>
+          </a:stretch>
+        </p:blipFill>
+        <p:spPr>
+          <a:xfrm>
+            <a:off x="457200" y="1188720"/>
+            <a:ext cx="8229600" cy="5878286"/>
+          </a:xfrm>
+          <a:prstGeom prst="rect">
+            <a:avLst/>
+          </a:prstGeom>
+        </p:spPr>
+      </p:pic>
     </p:spTree>
   </p:cSld>
   <p:clrMapOvr>
@@ -3798,7 +4026,7 @@
           <a:lstStyle/>
           <a:p>
             <a:r>
-              <a:t>SIP vs Lumpsum Trends</a:t>
+              <a:t>Investor Demographics</a:t>
             </a:r>
           </a:p>
         </p:txBody>
@@ -3819,7 +4047,25 @@
           <a:lstStyle/>
           <a:p>
             <a:r>
-              <a:t>Key points for SIP vs Lumpsum Trends go here.</a:t>
+              <a:t>SIP dominates for 25-35 age group</a:t>
+            </a:r>
+          </a:p>
+          <a:p>
+            <a:pPr lvl="1"/>
+            <a:r>
+              <a:t>T30 cities: ~70% of transaction volume</a:t>
+            </a:r>
+          </a:p>
+          <a:p>
+            <a:pPr lvl="1"/>
+            <a:r>
+              <a:t>KYC compliance rate: &gt;95% across all tiers</a:t>
+            </a:r>
+          </a:p>
+          <a:p>
+            <a:pPr lvl="1"/>
+            <a:r>
+              <a:t>Top states: Maharashtra, Karnataka, Delhi NCR</a:t>
             </a:r>
           </a:p>
         </p:txBody>

</xml_diff>